<commit_message>
Update milestone 5 documents
</commit_message>
<xml_diff>
--- a/docs/milestone_5/Milestone_5_Presentation.pptx
+++ b/docs/milestone_5/Milestone_5_Presentation.pptx
@@ -996,7 +996,116 @@
             </a:pPr>
             <a:r>
               <a:rPr lang="en"/>
-              <a:t>The NIST non-IID reference tool assessed the same first million lightning events using timestamp-byte, timestamp-bit and signed-amplitude-byte representations. The timestamp-byte estimate was 7.2620876454 bits per 8-bit sample. It is not a validated joint block entropy bound. SHA3 and Toeplitz output/provenance were implemented. Source-model validation and PQC integration remain future work.</a:t>
+              <a:t>Entropy describes how difficult the source is to predict. We assessed one million lightning events before hashing or mixing in operating-system randomness. We tested timestamp low bytes, timestamp low bits and signed-amplitude low bytes separately. The NIST non-IID estimates were 7.2621 bits per 8-bit timestamp sample, 0.8210 bits per 1-bit timestamp sample and 3.6798 bits per 8-bit amplitude sample. These are corpus estimates, not proof of independent samples or a validated secret-key entropy budget.</a:t>
+            </a:r>
+            <a:endParaRPr/>
+          </a:p>
+          <a:p>
+            <a:pPr indent="0" lvl="0" marL="0" rtl="0" algn="l">
+              <a:spcBef>
+                <a:spcPts val="0"/>
+              </a:spcBef>
+              <a:spcAft>
+                <a:spcPts val="0"/>
+              </a:spcAft>
+              <a:buNone/>
+            </a:pPr>
+            <a:r>
+              <a:t/>
+            </a:r>
+            <a:endParaRPr/>
+          </a:p>
+          <a:p>
+            <a:pPr indent="0" lvl="0" marL="0" rtl="0" algn="l">
+              <a:spcBef>
+                <a:spcPts val="0"/>
+              </a:spcBef>
+              <a:spcAft>
+                <a:spcPts val="0"/>
+              </a:spcAft>
+              <a:buNone/>
+            </a:pPr>
+            <a:r>
+              <a:rPr lang="en"/>
+              <a:t>SHA3 provides deterministic conditioning. Our Toeplitz implementation consumes 128 previously unused source bytes (1,024 input bits) and obtains a fresh 1,279-bit public OS seed to select the matrix for a 256-bit output. We retain the seed, consumed sample range and hashes so the calculation can be reproduced. The seed receives no lightning-entropy credit, and anyone with the complete input and seed can reproduce the result.</a:t>
+            </a:r>
+            <a:endParaRPr/>
+          </a:p>
+          <a:p>
+            <a:pPr indent="0" lvl="0" marL="0" rtl="0" algn="l">
+              <a:spcBef>
+                <a:spcPts val="0"/>
+              </a:spcBef>
+              <a:spcAft>
+                <a:spcPts val="0"/>
+              </a:spcAft>
+              <a:buNone/>
+            </a:pPr>
+            <a:r>
+              <a:t/>
+            </a:r>
+            <a:endParaRPr/>
+          </a:p>
+          <a:p>
+            <a:pPr indent="0" lvl="0" marL="0" rtl="0" algn="l">
+              <a:spcBef>
+                <a:spcPts val="0"/>
+              </a:spcBef>
+              <a:spcAft>
+                <a:spcPts val="0"/>
+              </a:spcAft>
+              <a:buNone/>
+            </a:pPr>
+            <a:r>
+              <a:rPr lang="en"/>
+              <a:t>Future work is to confirm sensor and timestamp behavior, assess dependence on unseen data, justify a conservative joint entropy bound, collect genuine restart data and calibrate repetition-count/adaptive-proportion health tests. The present per-symbol estimate alone does not guarantee 256 secret output bits.</a:t>
+            </a:r>
+            <a:endParaRPr/>
+          </a:p>
+          <a:p>
+            <a:pPr indent="0" lvl="0" marL="0" rtl="0" algn="l">
+              <a:spcBef>
+                <a:spcPts val="0"/>
+              </a:spcBef>
+              <a:spcAft>
+                <a:spcPts val="0"/>
+              </a:spcAft>
+              <a:buNone/>
+            </a:pPr>
+            <a:r>
+              <a:t/>
+            </a:r>
+            <a:endParaRPr/>
+          </a:p>
+          <a:p>
+            <a:pPr indent="0" lvl="0" marL="0" rtl="0" algn="l">
+              <a:spcBef>
+                <a:spcPts val="0"/>
+              </a:spcBef>
+              <a:spcAft>
+                <a:spcPts val="0"/>
+              </a:spcAft>
+              <a:buNone/>
+            </a:pPr>
+            <a:r>
+              <a:rPr lang="en"/>
+              <a:t>Sources: Lightning entropy assessment (October 15, 2026); Toeplitz extraction proof and implementation evidence and provisional source model (October 26, 2026).</a:t>
+            </a:r>
+            <a:endParaRPr/>
+          </a:p>
+          <a:p>
+            <a:pPr indent="0" lvl="0" marL="0" rtl="0" algn="l">
+              <a:spcBef>
+                <a:spcPts val="0"/>
+              </a:spcBef>
+              <a:spcAft>
+                <a:spcPts val="0"/>
+              </a:spcAft>
+              <a:buNone/>
+            </a:pPr>
+            <a:r>
+              <a:rPr lang="en"/>
+              <a:t>https://csrc.nist.gov/pubs/sp/800/90/b/final</a:t>
             </a:r>
             <a:endParaRPr/>
           </a:p>
@@ -12430,7 +12539,7 @@
             </a:pPr>
             <a:r>
               <a:rPr lang="en" sz="1800"/>
-              <a:t>Assessed 1,000,000 lightning events with the NIST non-IID tool.</a:t>
+              <a:t>Assessed 1,000,000 lightning events with the NIST non-IID tool to estimate unpredictability.</a:t>
             </a:r>
             <a:endParaRPr sz="1800"/>
           </a:p>
@@ -12450,7 +12559,7 @@
             </a:pPr>
             <a:r>
               <a:rPr lang="en" sz="1800"/>
-              <a:t>Timestamp bytes measured 7.2621 bits per 8-bit sample. This is a corpus estimate, not source validation.</a:t>
+              <a:t>Timestamp bytes: 7.2621 bits per 8-bit sample. Amplitude bytes: 3.6798. These estimates cannot simply be added.</a:t>
             </a:r>
             <a:endParaRPr sz="1800"/>
           </a:p>
@@ -12470,7 +12579,7 @@
             </a:pPr>
             <a:r>
               <a:rPr lang="en" sz="1800"/>
-              <a:t>Implemented SHA3 and Toeplitz output with downloadable provenance.</a:t>
+              <a:t>Implemented SHA3 and Toeplitz extraction. Toeplitz converts 128 source bytes into 256 output bits using a fresh public seed.</a:t>
             </a:r>
             <a:endParaRPr sz="1800"/>
           </a:p>
@@ -12490,7 +12599,7 @@
             </a:pPr>
             <a:r>
               <a:rPr lang="en" sz="1800"/>
-              <a:t>Next: validate source dependence and the joint entropy bound, then integrate PQC.</a:t>
+              <a:t>Next: validate dependence and joint input entropy, collect restart data, and add source-health tests.</a:t>
             </a:r>
             <a:endParaRPr sz="1800"/>
           </a:p>
@@ -12918,7 +13027,7 @@
             <a:tbl>
               <a:tblPr>
                 <a:noFill/>
-                <a:tableStyleId>{462DCEE4-3205-422B-AC97-C0F56D87B947}</a:tableStyleId>
+                <a:tableStyleId>{236F04E9-5020-487C-B299-A11F27DC5553}</a:tableStyleId>
               </a:tblPr>
               <a:tblGrid>
                 <a:gridCol w="2286000"/>
@@ -14497,7 +14606,7 @@
             <a:tbl>
               <a:tblPr>
                 <a:noFill/>
-                <a:tableStyleId>{462DCEE4-3205-422B-AC97-C0F56D87B947}</a:tableStyleId>
+                <a:tableStyleId>{236F04E9-5020-487C-B299-A11F27DC5553}</a:tableStyleId>
               </a:tblPr>
               <a:tblGrid>
                 <a:gridCol w="2921000"/>
@@ -15993,9 +16102,9 @@
 </file>
 
 <file path=ppt/theme/theme1.xml><?xml version="1.0" encoding="utf-8"?>
-<a:theme xmlns:a="http://schemas.openxmlformats.org/drawingml/2006/main" xmlns:r="http://schemas.openxmlformats.org/officeDocument/2006/relationships">
+<a:theme xmlns:a="http://schemas.openxmlformats.org/drawingml/2006/main" xmlns:r="http://schemas.openxmlformats.org/officeDocument/2006/relationships" name="Simple Light">
   <a:themeElements>
-    <a:clrScheme name="Default">
+    <a:clrScheme name="Simple Light">
       <a:dk1>
         <a:srgbClr val="000000"/>
       </a:dk1>
@@ -16003,34 +16112,34 @@
         <a:srgbClr val="FFFFFF"/>
       </a:lt1>
       <a:dk2>
-        <a:srgbClr val="158158"/>
+        <a:srgbClr val="595959"/>
       </a:dk2>
       <a:lt2>
-        <a:srgbClr val="F3F3F3"/>
+        <a:srgbClr val="EEEEEE"/>
       </a:lt2>
       <a:accent1>
-        <a:srgbClr val="058DC7"/>
+        <a:srgbClr val="4285F4"/>
       </a:accent1>
       <a:accent2>
-        <a:srgbClr val="50B432"/>
+        <a:srgbClr val="212121"/>
       </a:accent2>
       <a:accent3>
-        <a:srgbClr val="ED561B"/>
+        <a:srgbClr val="78909C"/>
       </a:accent3>
       <a:accent4>
-        <a:srgbClr val="EDEF00"/>
+        <a:srgbClr val="FFAB40"/>
       </a:accent4>
       <a:accent5>
-        <a:srgbClr val="24CBE5"/>
+        <a:srgbClr val="0097A7"/>
       </a:accent5>
       <a:accent6>
-        <a:srgbClr val="64E572"/>
+        <a:srgbClr val="EEFF41"/>
       </a:accent6>
       <a:hlink>
-        <a:srgbClr val="2200CC"/>
+        <a:srgbClr val="0097A7"/>
       </a:hlink>
       <a:folHlink>
-        <a:srgbClr val="551A8B"/>
+        <a:srgbClr val="0097A7"/>
       </a:folHlink>
     </a:clrScheme>
     <a:fontScheme name="Office">
@@ -16551,9 +16660,9 @@
 </file>
 
 <file path=ppt/theme/theme3.xml><?xml version="1.0" encoding="utf-8"?>
-<a:theme xmlns:a="http://schemas.openxmlformats.org/drawingml/2006/main" xmlns:r="http://schemas.openxmlformats.org/officeDocument/2006/relationships" name="Simple Light">
+<a:theme xmlns:a="http://schemas.openxmlformats.org/drawingml/2006/main" xmlns:r="http://schemas.openxmlformats.org/officeDocument/2006/relationships">
   <a:themeElements>
-    <a:clrScheme name="Simple Light">
+    <a:clrScheme name="Default">
       <a:dk1>
         <a:srgbClr val="000000"/>
       </a:dk1>
@@ -16561,34 +16670,34 @@
         <a:srgbClr val="FFFFFF"/>
       </a:lt1>
       <a:dk2>
-        <a:srgbClr val="595959"/>
+        <a:srgbClr val="158158"/>
       </a:dk2>
       <a:lt2>
-        <a:srgbClr val="EEEEEE"/>
+        <a:srgbClr val="F3F3F3"/>
       </a:lt2>
       <a:accent1>
-        <a:srgbClr val="4285F4"/>
+        <a:srgbClr val="058DC7"/>
       </a:accent1>
       <a:accent2>
-        <a:srgbClr val="212121"/>
+        <a:srgbClr val="50B432"/>
       </a:accent2>
       <a:accent3>
-        <a:srgbClr val="78909C"/>
+        <a:srgbClr val="ED561B"/>
       </a:accent3>
       <a:accent4>
-        <a:srgbClr val="FFAB40"/>
+        <a:srgbClr val="EDEF00"/>
       </a:accent4>
       <a:accent5>
-        <a:srgbClr val="0097A7"/>
+        <a:srgbClr val="24CBE5"/>
       </a:accent5>
       <a:accent6>
-        <a:srgbClr val="EEFF41"/>
+        <a:srgbClr val="64E572"/>
       </a:accent6>
       <a:hlink>
-        <a:srgbClr val="0097A7"/>
+        <a:srgbClr val="2200CC"/>
       </a:hlink>
       <a:folHlink>
-        <a:srgbClr val="0097A7"/>
+        <a:srgbClr val="551A8B"/>
       </a:folHlink>
     </a:clrScheme>
     <a:fontScheme name="Office">

</xml_diff>